<commit_message>
Think and Speak Session Donegit status!
</commit_message>
<xml_diff>
--- a/Read and Present/EO_OLATEJU_READ+PRESENT.pptx
+++ b/Read and Present/EO_OLATEJU_READ+PRESENT.pptx
@@ -3714,7 +3714,7 @@
         </p:nvSpPr>
         <p:spPr>
           <a:xfrm>
-            <a:off x="1524000" y="476624"/>
+            <a:off x="1524000" y="466464"/>
             <a:ext cx="9144000" cy="2698115"/>
           </a:xfrm>
         </p:spPr>
@@ -3735,8 +3735,8 @@
                   <a:srgbClr val="000000"/>
                 </a:solidFill>
                 <a:latin typeface="FreeSerif" panose="02020603050405020304"/>
-                <a:ea typeface="Roboto"/>
-                <a:cs typeface="Roboto"/>
+                <a:ea typeface="Roboto" panose="02000000000000000000"/>
+                <a:cs typeface="Roboto" panose="02000000000000000000"/>
               </a:rPr>
               <a:t>Learning </a:t>
             </a:r>
@@ -3746,8 +3746,8 @@
                   <a:srgbClr val="000000"/>
                 </a:solidFill>
                 <a:latin typeface="FreeSerif" panose="02020603050405020304"/>
-                <a:ea typeface="Roboto"/>
-                <a:cs typeface="Roboto"/>
+                <a:ea typeface="Roboto" panose="02000000000000000000"/>
+                <a:cs typeface="Roboto" panose="02000000000000000000"/>
               </a:rPr>
               <a:t>Latent Dynamics For Planning from Pixels</a:t>
             </a:r>
@@ -3757,8 +3757,8 @@
                   <a:srgbClr val="000000"/>
                 </a:solidFill>
                 <a:latin typeface="FreeSerif" panose="02020603050405020304"/>
-                <a:ea typeface="Roboto"/>
-                <a:cs typeface="Roboto"/>
+                <a:ea typeface="Roboto" panose="02000000000000000000"/>
+                <a:cs typeface="Roboto" panose="02000000000000000000"/>
               </a:rPr>
             </a:br>
             <a:br>
@@ -3767,8 +3767,8 @@
                   <a:srgbClr val="000000"/>
                 </a:solidFill>
                 <a:latin typeface="FreeSerif" panose="02020603050405020304"/>
-                <a:ea typeface="Roboto"/>
-                <a:cs typeface="Roboto"/>
+                <a:ea typeface="Roboto" panose="02000000000000000000"/>
+                <a:cs typeface="Roboto" panose="02000000000000000000"/>
               </a:rPr>
             </a:br>
             <a:br>
@@ -3777,8 +3777,8 @@
                   <a:srgbClr val="000000"/>
                 </a:solidFill>
                 <a:latin typeface="FreeSerif" panose="02020603050405020304"/>
-                <a:ea typeface="Roboto"/>
-                <a:cs typeface="Roboto"/>
+                <a:ea typeface="Roboto" panose="02000000000000000000"/>
+                <a:cs typeface="Roboto" panose="02000000000000000000"/>
               </a:rPr>
             </a:br>
             <a:r>
@@ -3787,8 +3787,8 @@
                   <a:srgbClr val="000000"/>
                 </a:solidFill>
                 <a:latin typeface="FreeSerif" panose="02020603050405020304"/>
-                <a:ea typeface="Roboto"/>
-                <a:cs typeface="Roboto"/>
+                <a:ea typeface="Roboto" panose="02000000000000000000"/>
+                <a:cs typeface="Roboto" panose="02000000000000000000"/>
               </a:rPr>
               <a:t>Danijar Hafner . Timothy Lillicrap . Ian Fischer . Ruben Villegas . David Ha. Honglak Lee . James Davidson</a:t>
             </a:r>
@@ -3797,8 +3797,8 @@
                 <a:srgbClr val="000000"/>
               </a:solidFill>
               <a:latin typeface="FreeSerif" panose="02020603050405020304"/>
-              <a:ea typeface="Roboto"/>
-              <a:cs typeface="Roboto"/>
+              <a:ea typeface="Roboto" panose="02000000000000000000"/>
+              <a:cs typeface="Roboto" panose="02000000000000000000"/>
             </a:endParaRPr>
           </a:p>
         </p:txBody>
@@ -3981,7 +3981,7 @@
                 <a:buAutoNum type="arabicPeriod"/>
               </a:pPr>
               <a:r>
-                <a:rPr lang="" altLang="en-US" sz="1200" b="1" i="1">
+                <a:rPr lang="en-US" altLang="en-US" sz="1200" b="1" i="1">
                   <a:latin typeface="FreeSerif" panose="02020603050405020304"/>
                 </a:rPr>
                 <a:t>Learning accurate models</a:t>
@@ -4475,12 +4475,12 @@
                 <a:buAutoNum type="arabicPeriod"/>
               </a:pPr>
               <a:r>
-                <a:rPr lang="" altLang="en-US" sz="1200" i="1">
+                <a:rPr lang="en-US" altLang="en-US" sz="1200" i="1">
                   <a:latin typeface="FreeSerif" panose="02020603050405020304"/>
                 </a:rPr>
                 <a:t>Learning of environment dynamics from images</a:t>
               </a:r>
-              <a:endParaRPr lang="" altLang="en-US" sz="1200" i="1">
+              <a:endParaRPr lang="en-US" altLang="en-US" sz="1200" i="1">
                 <a:latin typeface="FreeSerif" panose="02020603050405020304"/>
               </a:endParaRPr>
             </a:p>
@@ -4492,12 +4492,12 @@
                 <a:buAutoNum type="arabicPeriod"/>
               </a:pPr>
               <a:r>
-                <a:rPr lang="" altLang="en-US" sz="1200" b="1" i="1">
+                <a:rPr lang="en-US" altLang="en-US" sz="1200" b="1" i="1">
                   <a:latin typeface="FreeSerif" panose="02020603050405020304"/>
                 </a:rPr>
                 <a:t>Fast online planning in latent space</a:t>
               </a:r>
-              <a:endParaRPr lang="" altLang="en-US" sz="1200" b="1" i="1">
+              <a:endParaRPr lang="en-US" altLang="en-US" sz="1200" b="1" i="1">
                 <a:latin typeface="FreeSerif" panose="02020603050405020304"/>
               </a:endParaRPr>
             </a:p>
@@ -4509,12 +4509,12 @@
                 <a:buAutoNum type="arabicPeriod"/>
               </a:pPr>
               <a:r>
-                <a:rPr lang="" altLang="en-US" sz="1200" b="1" i="1">
+                <a:rPr lang="en-US" altLang="en-US" sz="1200" b="1" i="1">
                   <a:latin typeface="FreeSerif" panose="02020603050405020304"/>
                 </a:rPr>
                 <a:t>Multi-step prediction of rewards</a:t>
               </a:r>
-              <a:endParaRPr lang="" altLang="en-US" sz="1200" b="1" i="1">
+              <a:endParaRPr lang="en-US" altLang="en-US" sz="1200" b="1" i="1">
                 <a:latin typeface="FreeSerif" panose="02020603050405020304"/>
               </a:endParaRPr>
             </a:p>
@@ -4526,12 +4526,12 @@
                 <a:buAutoNum type="arabicPeriod"/>
               </a:pPr>
               <a:r>
-                <a:rPr lang="" altLang="en-US" sz="1200" i="1">
+                <a:rPr lang="en-US" altLang="en-US" sz="1200" i="1">
                   <a:latin typeface="FreeSerif" panose="02020603050405020304"/>
                 </a:rPr>
                 <a:t>Latent overshooting - variational inference</a:t>
               </a:r>
-              <a:endParaRPr lang="" altLang="en-US" sz="1200" i="1">
+              <a:endParaRPr lang="en-US" altLang="en-US" sz="1200" i="1">
                 <a:latin typeface="FreeSerif" panose="02020603050405020304"/>
               </a:endParaRPr>
             </a:p>
@@ -4573,7 +4573,7 @@
                 <a:buNone/>
               </a:pPr>
               <a:r>
-                <a:rPr lang="" altLang="en-US" sz="1200" i="1">
+                <a:rPr lang="en-US" altLang="en-US" sz="1200" i="1">
                   <a:solidFill>
                     <a:schemeClr val="bg1"/>
                   </a:solidFill>
@@ -4581,7 +4581,7 @@
                 </a:rPr>
                 <a:t>PlaNet</a:t>
               </a:r>
-              <a:endParaRPr lang="" altLang="en-US" sz="1200" i="1">
+              <a:endParaRPr lang="en-US" altLang="en-US" sz="1200" i="1">
                 <a:solidFill>
                   <a:schemeClr val="bg1"/>
                 </a:solidFill>
@@ -5699,13 +5699,13 @@
           </a:bodyPr>
           <a:p>
             <a:r>
-              <a:rPr lang="" altLang="en-US" sz="1200" b="1">
+              <a:rPr lang="en-US" altLang="en-US" sz="1200" b="1">
                 <a:latin typeface="FreeSerif" panose="02020603050405020304" charset="0"/>
                 <a:cs typeface="FreeSerif" panose="02020603050405020304" charset="0"/>
               </a:rPr>
               <a:t>Planning Objective</a:t>
             </a:r>
-            <a:endParaRPr lang="" altLang="en-US" sz="1200" b="1">
+            <a:endParaRPr lang="en-US" altLang="en-US" sz="1200" b="1">
               <a:latin typeface="FreeSerif" panose="02020603050405020304" charset="0"/>
               <a:cs typeface="FreeSerif" panose="02020603050405020304" charset="0"/>
             </a:endParaRPr>
@@ -5774,13 +5774,13 @@
           </a:bodyPr>
           <a:p>
             <a:r>
-              <a:rPr lang="" altLang="en-US" sz="1200" b="1">
+              <a:rPr lang="en-US" altLang="en-US" sz="1200" b="1">
                 <a:latin typeface="FreeSerif" panose="02020603050405020304" charset="0"/>
                 <a:cs typeface="FreeSerif" panose="02020603050405020304" charset="0"/>
               </a:rPr>
               <a:t>Policy</a:t>
             </a:r>
-            <a:endParaRPr lang="" altLang="en-US" sz="1200" b="1">
+            <a:endParaRPr lang="en-US" altLang="en-US" sz="1200" b="1">
               <a:latin typeface="FreeSerif" panose="02020603050405020304" charset="0"/>
               <a:cs typeface="FreeSerif" panose="02020603050405020304" charset="0"/>
             </a:endParaRPr>
@@ -7336,26 +7336,26 @@
           </a:bodyPr>
           <a:p>
             <a:r>
-              <a:rPr lang="" altLang="en-US" sz="1200" b="1">
+              <a:rPr lang="en-US" altLang="en-US" sz="1200" b="1">
                 <a:latin typeface="FreeSerif" panose="02020603050405020304" charset="0"/>
                 <a:cs typeface="FreeSerif" panose="02020603050405020304" charset="0"/>
               </a:rPr>
               <a:t>Approximate</a:t>
             </a:r>
             <a:br>
-              <a:rPr lang="" altLang="en-US" sz="1200" b="1">
+              <a:rPr lang="en-US" altLang="en-US" sz="1200" b="1">
                 <a:latin typeface="FreeSerif" panose="02020603050405020304" charset="0"/>
                 <a:cs typeface="FreeSerif" panose="02020603050405020304" charset="0"/>
               </a:rPr>
             </a:br>
             <a:r>
-              <a:rPr lang="" altLang="en-US" sz="1200" b="1">
+              <a:rPr lang="en-US" altLang="en-US" sz="1200" b="1">
                 <a:latin typeface="FreeSerif" panose="02020603050405020304" charset="0"/>
                 <a:cs typeface="FreeSerif" panose="02020603050405020304" charset="0"/>
               </a:rPr>
               <a:t>Posterior</a:t>
             </a:r>
-            <a:endParaRPr lang="" altLang="en-US" sz="1200" b="1">
+            <a:endParaRPr lang="en-US" altLang="en-US" sz="1200" b="1">
               <a:latin typeface="FreeSerif" panose="02020603050405020304" charset="0"/>
               <a:cs typeface="FreeSerif" panose="02020603050405020304" charset="0"/>
             </a:endParaRPr>
@@ -8106,13 +8106,7 @@
                 <a:rPr lang="en-US" altLang="en-US" sz="1200" b="1" i="1">
                   <a:latin typeface="FreeSerif" panose="02020603050405020304"/>
                 </a:rPr>
-                <a:t>Learn a value function to approximate rewards beyond the planning horizon </a:t>
-              </a:r>
-              <a:r>
-                <a:rPr lang="" altLang="en-US" sz="1200" b="1" i="1">
-                  <a:latin typeface="FreeSerif" panose="02020603050405020304"/>
-                </a:rPr>
-                <a:t>- DREAMER</a:t>
+                <a:t>Learn a value function to approximate rewards beyond the planning horizon - DREAMER</a:t>
               </a:r>
               <a:endParaRPr lang="en-US" altLang="en-US" sz="1200" b="1" i="1">
                 <a:latin typeface="FreeSerif" panose="02020603050405020304"/>

</xml_diff>